<commit_message>
Add live link of the project
</commit_message>
<xml_diff>
--- a/slides/Python_QnA_Assistant.pptx
+++ b/slides/Python_QnA_Assistant.pptx
@@ -1933,7 +1933,7 @@
         </p:nvSpPr>
         <p:spPr>
           <a:xfrm>
-            <a:off x="640080" y="3246120"/>
+            <a:off x="640080" y="3182112"/>
             <a:ext cx="7498080" cy="457200"/>
           </a:xfrm>
           <a:prstGeom prst="rect">
@@ -1972,8 +1972,8 @@
         </p:nvSpPr>
         <p:spPr>
           <a:xfrm>
-            <a:off x="640080" y="3977640"/>
-            <a:ext cx="7315200" cy="320040"/>
+            <a:off x="640080" y="3703320"/>
+            <a:ext cx="7863840" cy="292608"/>
           </a:xfrm>
           <a:prstGeom prst="rect">
             <a:avLst/>
@@ -1997,13 +1997,73 @@
                 <a:ea typeface="Calibri" pitchFamily="34" charset="-122"/>
                 <a:cs typeface="Calibri" pitchFamily="34" charset="-120"/>
               </a:rPr>
+              <a:t>Live demo   </a:t>
+            </a:r>
+            <a:pPr indent="0" marL="0">
+              <a:buNone/>
+            </a:pPr>
+            <a:r>
+              <a:rPr lang="en-US" sz="1500" b="1" u="sng" dirty="0">
+                <a:solidFill>
+                  <a:srgbClr val="5EEAD4"/>
+                </a:solidFill>
+                <a:latin typeface="Calibri" pitchFamily="34" charset="0"/>
+                <a:ea typeface="Calibri" pitchFamily="34" charset="-122"/>
+                <a:cs typeface="Calibri" pitchFamily="34" charset="-120"/>
+                <a:hlinkClick r:id="rId1" invalidUrl="" action="" tgtFrame="" tooltip="" history="1" highlightClick="0" endSnd="0">
+                  <a:extLst>
+                    <a:ext uri="{A12FA001-AC4F-418D-AE19-62706E023703}">
+                      <ahyp:hlinkClr xmlns:ahyp="http://schemas.microsoft.com/office/drawing/2018/hyperlinkcolor" val="tx"/>
+                    </a:ext>
+                  </a:extLst>
+                </a:hlinkClick>
+              </a:rPr>
+              <a:t>python-qna-assistant.streamlit.app</a:t>
+            </a:r>
+            <a:endParaRPr lang="en-US" sz="1500" dirty="0"/>
+          </a:p>
+        </p:txBody>
+      </p:sp>
+      <p:sp>
+        <p:nvSpPr>
+          <p:cNvPr id="8" name="Text 6"/>
+          <p:cNvSpPr/>
+          <p:nvPr/>
+        </p:nvSpPr>
+        <p:spPr>
+          <a:xfrm>
+            <a:off x="640080" y="4114800"/>
+            <a:ext cx="7315200" cy="292608"/>
+          </a:xfrm>
+          <a:prstGeom prst="rect">
+            <a:avLst/>
+          </a:prstGeom>
+          <a:noFill/>
+          <a:ln/>
+        </p:spPr>
+        <p:txBody>
+          <a:bodyPr wrap="square" lIns="0" tIns="0" rIns="0" bIns="0" rtlCol="0" anchor="ctr"/>
+          <a:lstStyle/>
+          <a:p>
+            <a:pPr indent="0" marL="0">
+              <a:buNone/>
+            </a:pPr>
+            <a:r>
+              <a:rPr lang="en-US" sz="1400" dirty="0">
+                <a:solidFill>
+                  <a:srgbClr val="94A3B8"/>
+                </a:solidFill>
+                <a:latin typeface="Calibri" pitchFamily="34" charset="0"/>
+                <a:ea typeface="Calibri" pitchFamily="34" charset="-122"/>
+                <a:cs typeface="Calibri" pitchFamily="34" charset="-120"/>
+              </a:rPr>
               <a:t>Built by  </a:t>
             </a:r>
             <a:pPr indent="0" marL="0">
               <a:buNone/>
             </a:pPr>
             <a:r>
-              <a:rPr lang="en-US" sz="1500" b="1" dirty="0">
+              <a:rPr lang="en-US" sz="1400" b="1" dirty="0">
                 <a:solidFill>
                   <a:srgbClr val="FFFFFF"/>
                 </a:solidFill>
@@ -2013,19 +2073,19 @@
               </a:rPr>
               <a:t>Vaibhav Yadav</a:t>
             </a:r>
-            <a:endParaRPr lang="en-US" sz="1500" dirty="0"/>
-          </a:p>
-        </p:txBody>
-      </p:sp>
-      <p:sp>
-        <p:nvSpPr>
-          <p:cNvPr id="8" name="Text 6"/>
-          <p:cNvSpPr/>
-          <p:nvPr/>
-        </p:nvSpPr>
-        <p:spPr>
-          <a:xfrm>
-            <a:off x="640080" y="4572000"/>
+            <a:endParaRPr lang="en-US" sz="1400" dirty="0"/>
+          </a:p>
+        </p:txBody>
+      </p:sp>
+      <p:sp>
+        <p:nvSpPr>
+          <p:cNvPr id="9" name="Text 7"/>
+          <p:cNvSpPr/>
+          <p:nvPr/>
+        </p:nvSpPr>
+        <p:spPr>
+          <a:xfrm>
+            <a:off x="640080" y="4526280"/>
             <a:ext cx="7863840" cy="320040"/>
           </a:xfrm>
           <a:prstGeom prst="rect">
@@ -2042,7 +2102,7 @@
               <a:buNone/>
             </a:pPr>
             <a:r>
-              <a:rPr lang="en-US" sz="1300" dirty="0">
+              <a:rPr lang="en-US" sz="1250" dirty="0">
                 <a:solidFill>
                   <a:srgbClr val="94A3B8"/>
                 </a:solidFill>
@@ -2052,7 +2112,7 @@
               </a:rPr>
               <a:t>FastAPI  ·  FAISS  ·  bge-small  ·  Groq Llama 3.3 70B</a:t>
             </a:r>
-            <a:endParaRPr lang="en-US" sz="1300" dirty="0"/>
+            <a:endParaRPr lang="en-US" sz="1250" dirty="0"/>
           </a:p>
         </p:txBody>
       </p:sp>

</xml_diff>